<commit_message>
datapaper figures, fin observer matrix and WIP map
</commit_message>
<xml_diff>
--- a/figures/datapaper/scratch_routeyearcombo.pptx
+++ b/figures/datapaper/scratch_routeyearcombo.pptx
@@ -6,6 +6,8 @@
   </p:sldMasterIdLst>
   <p:sldIdLst>
     <p:sldId id="256" r:id="rId2"/>
+    <p:sldId id="257" r:id="rId3"/>
+    <p:sldId id="258" r:id="rId4"/>
   </p:sldIdLst>
   <p:sldSz cx="12192000" cy="6858000"/>
   <p:notesSz cx="6858000" cy="9144000"/>
@@ -259,7 +261,7 @@
           <a:p>
             <a:fld id="{E3CAC27E-A09F-42ED-BD9F-2DE2B5FBE76A}" type="datetimeFigureOut">
               <a:rPr lang="en-US" smtClean="0"/>
-              <a:t>2/10/2026</a:t>
+              <a:t>6/2/2026</a:t>
             </a:fld>
             <a:endParaRPr lang="en-US"/>
           </a:p>
@@ -457,7 +459,7 @@
           <a:p>
             <a:fld id="{E3CAC27E-A09F-42ED-BD9F-2DE2B5FBE76A}" type="datetimeFigureOut">
               <a:rPr lang="en-US" smtClean="0"/>
-              <a:t>2/10/2026</a:t>
+              <a:t>6/2/2026</a:t>
             </a:fld>
             <a:endParaRPr lang="en-US"/>
           </a:p>
@@ -665,7 +667,7 @@
           <a:p>
             <a:fld id="{E3CAC27E-A09F-42ED-BD9F-2DE2B5FBE76A}" type="datetimeFigureOut">
               <a:rPr lang="en-US" smtClean="0"/>
-              <a:t>2/10/2026</a:t>
+              <a:t>6/2/2026</a:t>
             </a:fld>
             <a:endParaRPr lang="en-US"/>
           </a:p>
@@ -863,7 +865,7 @@
           <a:p>
             <a:fld id="{E3CAC27E-A09F-42ED-BD9F-2DE2B5FBE76A}" type="datetimeFigureOut">
               <a:rPr lang="en-US" smtClean="0"/>
-              <a:t>2/10/2026</a:t>
+              <a:t>6/2/2026</a:t>
             </a:fld>
             <a:endParaRPr lang="en-US"/>
           </a:p>
@@ -1138,7 +1140,7 @@
           <a:p>
             <a:fld id="{E3CAC27E-A09F-42ED-BD9F-2DE2B5FBE76A}" type="datetimeFigureOut">
               <a:rPr lang="en-US" smtClean="0"/>
-              <a:t>2/10/2026</a:t>
+              <a:t>6/2/2026</a:t>
             </a:fld>
             <a:endParaRPr lang="en-US"/>
           </a:p>
@@ -1403,7 +1405,7 @@
           <a:p>
             <a:fld id="{E3CAC27E-A09F-42ED-BD9F-2DE2B5FBE76A}" type="datetimeFigureOut">
               <a:rPr lang="en-US" smtClean="0"/>
-              <a:t>2/10/2026</a:t>
+              <a:t>6/2/2026</a:t>
             </a:fld>
             <a:endParaRPr lang="en-US"/>
           </a:p>
@@ -1815,7 +1817,7 @@
           <a:p>
             <a:fld id="{E3CAC27E-A09F-42ED-BD9F-2DE2B5FBE76A}" type="datetimeFigureOut">
               <a:rPr lang="en-US" smtClean="0"/>
-              <a:t>2/10/2026</a:t>
+              <a:t>6/2/2026</a:t>
             </a:fld>
             <a:endParaRPr lang="en-US"/>
           </a:p>
@@ -1956,7 +1958,7 @@
           <a:p>
             <a:fld id="{E3CAC27E-A09F-42ED-BD9F-2DE2B5FBE76A}" type="datetimeFigureOut">
               <a:rPr lang="en-US" smtClean="0"/>
-              <a:t>2/10/2026</a:t>
+              <a:t>6/2/2026</a:t>
             </a:fld>
             <a:endParaRPr lang="en-US"/>
           </a:p>
@@ -2069,7 +2071,7 @@
           <a:p>
             <a:fld id="{E3CAC27E-A09F-42ED-BD9F-2DE2B5FBE76A}" type="datetimeFigureOut">
               <a:rPr lang="en-US" smtClean="0"/>
-              <a:t>2/10/2026</a:t>
+              <a:t>6/2/2026</a:t>
             </a:fld>
             <a:endParaRPr lang="en-US"/>
           </a:p>
@@ -2380,7 +2382,7 @@
           <a:p>
             <a:fld id="{E3CAC27E-A09F-42ED-BD9F-2DE2B5FBE76A}" type="datetimeFigureOut">
               <a:rPr lang="en-US" smtClean="0"/>
-              <a:t>2/10/2026</a:t>
+              <a:t>6/2/2026</a:t>
             </a:fld>
             <a:endParaRPr lang="en-US"/>
           </a:p>
@@ -2668,7 +2670,7 @@
           <a:p>
             <a:fld id="{E3CAC27E-A09F-42ED-BD9F-2DE2B5FBE76A}" type="datetimeFigureOut">
               <a:rPr lang="en-US" smtClean="0"/>
-              <a:t>2/10/2026</a:t>
+              <a:t>6/2/2026</a:t>
             </a:fld>
             <a:endParaRPr lang="en-US"/>
           </a:p>
@@ -2909,7 +2911,7 @@
           <a:p>
             <a:fld id="{E3CAC27E-A09F-42ED-BD9F-2DE2B5FBE76A}" type="datetimeFigureOut">
               <a:rPr lang="en-US" smtClean="0"/>
-              <a:t>2/10/2026</a:t>
+              <a:t>6/2/2026</a:t>
             </a:fld>
             <a:endParaRPr lang="en-US"/>
           </a:p>
@@ -3413,6 +3415,462 @@
 </p:sld>
 </file>
 
+<file path=ppt/slides/slide2.xml><?xml version="1.0" encoding="utf-8"?>
+<p:sld xmlns:a="http://schemas.openxmlformats.org/drawingml/2006/main" xmlns:r="http://schemas.openxmlformats.org/officeDocument/2006/relationships" xmlns:p="http://schemas.openxmlformats.org/presentationml/2006/main">
+  <p:cSld>
+    <p:spTree>
+      <p:nvGrpSpPr>
+        <p:cNvPr id="1" name=""/>
+        <p:cNvGrpSpPr/>
+        <p:nvPr/>
+      </p:nvGrpSpPr>
+      <p:grpSpPr>
+        <a:xfrm>
+          <a:off x="0" y="0"/>
+          <a:ext cx="0" cy="0"/>
+          <a:chOff x="0" y="0"/>
+          <a:chExt cx="0" cy="0"/>
+        </a:xfrm>
+      </p:grpSpPr>
+      <p:pic>
+        <p:nvPicPr>
+          <p:cNvPr id="2" name="Picture 1">
+            <a:extLst>
+              <a:ext uri="{FF2B5EF4-FFF2-40B4-BE49-F238E27FC236}">
+                <a16:creationId xmlns:a16="http://schemas.microsoft.com/office/drawing/2014/main" id="{D8968413-F466-57FD-67F2-80B58257210C}"/>
+              </a:ext>
+            </a:extLst>
+          </p:cNvPr>
+          <p:cNvPicPr>
+            <a:picLocks noChangeAspect="1"/>
+          </p:cNvPicPr>
+          <p:nvPr/>
+        </p:nvPicPr>
+        <p:blipFill>
+          <a:blip r:embed="rId2">
+            <a:extLst>
+              <a:ext uri="{28A0092B-C50C-407E-A947-70E740481C1C}">
+                <a14:useLocalDpi xmlns:a14="http://schemas.microsoft.com/office/drawing/2010/main" val="0"/>
+              </a:ext>
+            </a:extLst>
+          </a:blip>
+          <a:srcRect l="2222" b="4276"/>
+          <a:stretch>
+            <a:fillRect/>
+          </a:stretch>
+        </p:blipFill>
+        <p:spPr>
+          <a:xfrm>
+            <a:off x="5268332" y="1374793"/>
+            <a:ext cx="5029201" cy="4832369"/>
+          </a:xfrm>
+          <a:prstGeom prst="rect">
+            <a:avLst/>
+          </a:prstGeom>
+        </p:spPr>
+      </p:pic>
+      <p:pic>
+        <p:nvPicPr>
+          <p:cNvPr id="13" name="Picture 12">
+            <a:extLst>
+              <a:ext uri="{FF2B5EF4-FFF2-40B4-BE49-F238E27FC236}">
+                <a16:creationId xmlns:a16="http://schemas.microsoft.com/office/drawing/2014/main" id="{ED49CCF5-BA0C-63D1-22A2-8BD010389E0A}"/>
+              </a:ext>
+            </a:extLst>
+          </p:cNvPr>
+          <p:cNvPicPr>
+            <a:picLocks noChangeAspect="1"/>
+          </p:cNvPicPr>
+          <p:nvPr/>
+        </p:nvPicPr>
+        <p:blipFill>
+          <a:blip r:embed="rId3">
+            <a:extLst>
+              <a:ext uri="{28A0092B-C50C-407E-A947-70E740481C1C}">
+                <a14:useLocalDpi xmlns:a14="http://schemas.microsoft.com/office/drawing/2010/main" val="0"/>
+              </a:ext>
+            </a:extLst>
+          </a:blip>
+          <a:stretch>
+            <a:fillRect/>
+          </a:stretch>
+        </p:blipFill>
+        <p:spPr>
+          <a:xfrm>
+            <a:off x="5211182" y="1374793"/>
+            <a:ext cx="5143500" cy="5048250"/>
+          </a:xfrm>
+          <a:prstGeom prst="rect">
+            <a:avLst/>
+          </a:prstGeom>
+        </p:spPr>
+      </p:pic>
+      <p:pic>
+        <p:nvPicPr>
+          <p:cNvPr id="3" name="Picture 2">
+            <a:extLst>
+              <a:ext uri="{FF2B5EF4-FFF2-40B4-BE49-F238E27FC236}">
+                <a16:creationId xmlns:a16="http://schemas.microsoft.com/office/drawing/2014/main" id="{BD4B2338-5A8C-5E76-7DF8-4F48845E01DA}"/>
+              </a:ext>
+            </a:extLst>
+          </p:cNvPr>
+          <p:cNvPicPr>
+            <a:picLocks noChangeAspect="1"/>
+          </p:cNvPicPr>
+          <p:nvPr/>
+        </p:nvPicPr>
+        <p:blipFill>
+          <a:blip r:embed="rId4">
+            <a:extLst>
+              <a:ext uri="{28A0092B-C50C-407E-A947-70E740481C1C}">
+                <a14:useLocalDpi xmlns:a14="http://schemas.microsoft.com/office/drawing/2010/main" val="0"/>
+              </a:ext>
+            </a:extLst>
+          </a:blip>
+          <a:srcRect l="10755" t="10862" r="68868" b="73289"/>
+          <a:stretch>
+            <a:fillRect/>
+          </a:stretch>
+        </p:blipFill>
+        <p:spPr>
+          <a:xfrm>
+            <a:off x="4229100" y="1643743"/>
+            <a:ext cx="1028700" cy="800100"/>
+          </a:xfrm>
+          <a:prstGeom prst="rect">
+            <a:avLst/>
+          </a:prstGeom>
+        </p:spPr>
+      </p:pic>
+      <p:pic>
+        <p:nvPicPr>
+          <p:cNvPr id="15" name="Picture 14">
+            <a:extLst>
+              <a:ext uri="{FF2B5EF4-FFF2-40B4-BE49-F238E27FC236}">
+                <a16:creationId xmlns:a16="http://schemas.microsoft.com/office/drawing/2014/main" id="{163768FB-D202-05A6-0ECB-D6843DCEDE63}"/>
+              </a:ext>
+            </a:extLst>
+          </p:cNvPr>
+          <p:cNvPicPr>
+            <a:picLocks noChangeAspect="1"/>
+          </p:cNvPicPr>
+          <p:nvPr/>
+        </p:nvPicPr>
+        <p:blipFill>
+          <a:blip r:embed="rId5">
+            <a:extLst>
+              <a:ext uri="{28A0092B-C50C-407E-A947-70E740481C1C}">
+                <a14:useLocalDpi xmlns:a14="http://schemas.microsoft.com/office/drawing/2010/main" val="0"/>
+              </a:ext>
+            </a:extLst>
+          </a:blip>
+          <a:srcRect l="9547" t="10360" r="66395" b="76264"/>
+          <a:stretch>
+            <a:fillRect/>
+          </a:stretch>
+        </p:blipFill>
+        <p:spPr>
+          <a:xfrm>
+            <a:off x="3996690" y="1643743"/>
+            <a:ext cx="1214492" cy="675258"/>
+          </a:xfrm>
+          <a:prstGeom prst="rect">
+            <a:avLst/>
+          </a:prstGeom>
+        </p:spPr>
+      </p:pic>
+      <p:pic>
+        <p:nvPicPr>
+          <p:cNvPr id="17" name="Picture 16">
+            <a:extLst>
+              <a:ext uri="{FF2B5EF4-FFF2-40B4-BE49-F238E27FC236}">
+                <a16:creationId xmlns:a16="http://schemas.microsoft.com/office/drawing/2014/main" id="{9329D204-D917-5EF4-1505-98BF97397791}"/>
+              </a:ext>
+            </a:extLst>
+          </p:cNvPr>
+          <p:cNvPicPr>
+            <a:picLocks noChangeAspect="1"/>
+          </p:cNvPicPr>
+          <p:nvPr/>
+        </p:nvPicPr>
+        <p:blipFill>
+          <a:blip r:embed="rId6">
+            <a:extLst>
+              <a:ext uri="{28A0092B-C50C-407E-A947-70E740481C1C}">
+                <a14:useLocalDpi xmlns:a14="http://schemas.microsoft.com/office/drawing/2010/main" val="0"/>
+              </a:ext>
+            </a:extLst>
+          </a:blip>
+          <a:srcRect l="8415" t="9308" r="62679" b="67208"/>
+          <a:stretch>
+            <a:fillRect/>
+          </a:stretch>
+        </p:blipFill>
+        <p:spPr>
+          <a:xfrm>
+            <a:off x="3832411" y="1643743"/>
+            <a:ext cx="1459230" cy="1185527"/>
+          </a:xfrm>
+          <a:prstGeom prst="rect">
+            <a:avLst/>
+          </a:prstGeom>
+        </p:spPr>
+      </p:pic>
+    </p:spTree>
+    <p:extLst>
+      <p:ext uri="{BB962C8B-B14F-4D97-AF65-F5344CB8AC3E}">
+        <p14:creationId xmlns:p14="http://schemas.microsoft.com/office/powerpoint/2010/main" val="1832604631"/>
+      </p:ext>
+    </p:extLst>
+  </p:cSld>
+  <p:clrMapOvr>
+    <a:masterClrMapping/>
+  </p:clrMapOvr>
+</p:sld>
+</file>
+
+<file path=ppt/slides/slide3.xml><?xml version="1.0" encoding="utf-8"?>
+<p:sld xmlns:a="http://schemas.openxmlformats.org/drawingml/2006/main" xmlns:r="http://schemas.openxmlformats.org/officeDocument/2006/relationships" xmlns:p="http://schemas.openxmlformats.org/presentationml/2006/main">
+  <p:cSld>
+    <p:spTree>
+      <p:nvGrpSpPr>
+        <p:cNvPr id="1" name=""/>
+        <p:cNvGrpSpPr/>
+        <p:nvPr/>
+      </p:nvGrpSpPr>
+      <p:grpSpPr>
+        <a:xfrm>
+          <a:off x="0" y="0"/>
+          <a:ext cx="0" cy="0"/>
+          <a:chOff x="0" y="0"/>
+          <a:chExt cx="0" cy="0"/>
+        </a:xfrm>
+      </p:grpSpPr>
+      <p:pic>
+        <p:nvPicPr>
+          <p:cNvPr id="3" name="Picture 2">
+            <a:extLst>
+              <a:ext uri="{FF2B5EF4-FFF2-40B4-BE49-F238E27FC236}">
+                <a16:creationId xmlns:a16="http://schemas.microsoft.com/office/drawing/2014/main" id="{C6B29AED-33F6-8862-CA08-D03D27E93F0B}"/>
+              </a:ext>
+            </a:extLst>
+          </p:cNvPr>
+          <p:cNvPicPr>
+            <a:picLocks noChangeAspect="1"/>
+          </p:cNvPicPr>
+          <p:nvPr/>
+        </p:nvPicPr>
+        <p:blipFill>
+          <a:blip r:embed="rId2"/>
+          <a:stretch>
+            <a:fillRect/>
+          </a:stretch>
+        </p:blipFill>
+        <p:spPr>
+          <a:xfrm>
+            <a:off x="2566987" y="800100"/>
+            <a:ext cx="7058025" cy="5257800"/>
+          </a:xfrm>
+          <a:prstGeom prst="rect">
+            <a:avLst/>
+          </a:prstGeom>
+        </p:spPr>
+      </p:pic>
+      <p:cxnSp>
+        <p:nvCxnSpPr>
+          <p:cNvPr id="5" name="Straight Connector 4">
+            <a:extLst>
+              <a:ext uri="{FF2B5EF4-FFF2-40B4-BE49-F238E27FC236}">
+                <a16:creationId xmlns:a16="http://schemas.microsoft.com/office/drawing/2014/main" id="{C366AA85-701F-DD92-AD55-D97127272ACD}"/>
+              </a:ext>
+            </a:extLst>
+          </p:cNvPr>
+          <p:cNvCxnSpPr>
+            <a:cxnSpLocks/>
+          </p:cNvCxnSpPr>
+          <p:nvPr/>
+        </p:nvCxnSpPr>
+        <p:spPr>
+          <a:xfrm>
+            <a:off x="4314825" y="1162050"/>
+            <a:ext cx="3543300" cy="0"/>
+          </a:xfrm>
+          <a:prstGeom prst="line">
+            <a:avLst/>
+          </a:prstGeom>
+          <a:ln w="9525"/>
+        </p:spPr>
+        <p:style>
+          <a:lnRef idx="2">
+            <a:schemeClr val="dk1"/>
+          </a:lnRef>
+          <a:fillRef idx="0">
+            <a:schemeClr val="dk1"/>
+          </a:fillRef>
+          <a:effectRef idx="1">
+            <a:schemeClr val="dk1"/>
+          </a:effectRef>
+          <a:fontRef idx="minor">
+            <a:schemeClr val="tx1"/>
+          </a:fontRef>
+        </p:style>
+      </p:cxnSp>
+      <p:cxnSp>
+        <p:nvCxnSpPr>
+          <p:cNvPr id="6" name="Straight Connector 5">
+            <a:extLst>
+              <a:ext uri="{FF2B5EF4-FFF2-40B4-BE49-F238E27FC236}">
+                <a16:creationId xmlns:a16="http://schemas.microsoft.com/office/drawing/2014/main" id="{6C92EFB3-481B-1D0E-7F2E-B3B66810FA9E}"/>
+              </a:ext>
+            </a:extLst>
+          </p:cNvPr>
+          <p:cNvCxnSpPr>
+            <a:cxnSpLocks/>
+          </p:cNvCxnSpPr>
+          <p:nvPr/>
+        </p:nvCxnSpPr>
+        <p:spPr>
+          <a:xfrm>
+            <a:off x="7858125" y="1162050"/>
+            <a:ext cx="0" cy="4524375"/>
+          </a:xfrm>
+          <a:prstGeom prst="line">
+            <a:avLst/>
+          </a:prstGeom>
+          <a:ln w="9525"/>
+        </p:spPr>
+        <p:style>
+          <a:lnRef idx="2">
+            <a:schemeClr val="dk1"/>
+          </a:lnRef>
+          <a:fillRef idx="0">
+            <a:schemeClr val="dk1"/>
+          </a:fillRef>
+          <a:effectRef idx="1">
+            <a:schemeClr val="dk1"/>
+          </a:effectRef>
+          <a:fontRef idx="minor">
+            <a:schemeClr val="tx1"/>
+          </a:fontRef>
+        </p:style>
+      </p:cxnSp>
+      <p:sp>
+        <p:nvSpPr>
+          <p:cNvPr id="10" name="Rectangle 9">
+            <a:extLst>
+              <a:ext uri="{FF2B5EF4-FFF2-40B4-BE49-F238E27FC236}">
+                <a16:creationId xmlns:a16="http://schemas.microsoft.com/office/drawing/2014/main" id="{0E69D264-4C7E-1477-B520-9937B2A464A1}"/>
+              </a:ext>
+            </a:extLst>
+          </p:cNvPr>
+          <p:cNvSpPr/>
+          <p:nvPr/>
+        </p:nvSpPr>
+        <p:spPr>
+          <a:xfrm>
+            <a:off x="3676650" y="5695950"/>
+            <a:ext cx="628650" cy="371470"/>
+          </a:xfrm>
+          <a:prstGeom prst="rect">
+            <a:avLst/>
+          </a:prstGeom>
+          <a:solidFill>
+            <a:schemeClr val="bg1"/>
+          </a:solidFill>
+          <a:ln>
+            <a:solidFill>
+              <a:schemeClr val="bg1"/>
+            </a:solidFill>
+          </a:ln>
+        </p:spPr>
+        <p:style>
+          <a:lnRef idx="2">
+            <a:schemeClr val="accent6"/>
+          </a:lnRef>
+          <a:fillRef idx="1">
+            <a:schemeClr val="lt1"/>
+          </a:fillRef>
+          <a:effectRef idx="0">
+            <a:schemeClr val="accent6"/>
+          </a:effectRef>
+          <a:fontRef idx="minor">
+            <a:schemeClr val="dk1"/>
+          </a:fontRef>
+        </p:style>
+        <p:txBody>
+          <a:bodyPr rtlCol="0" anchor="ctr"/>
+          <a:lstStyle/>
+          <a:p>
+            <a:pPr algn="ctr"/>
+            <a:endParaRPr lang="en-US"/>
+          </a:p>
+        </p:txBody>
+      </p:sp>
+      <p:sp>
+        <p:nvSpPr>
+          <p:cNvPr id="11" name="Rectangle 10">
+            <a:extLst>
+              <a:ext uri="{FF2B5EF4-FFF2-40B4-BE49-F238E27FC236}">
+                <a16:creationId xmlns:a16="http://schemas.microsoft.com/office/drawing/2014/main" id="{9782BB83-9B52-0FD7-F7E1-51BEAE90425F}"/>
+              </a:ext>
+            </a:extLst>
+          </p:cNvPr>
+          <p:cNvSpPr/>
+          <p:nvPr/>
+        </p:nvSpPr>
+        <p:spPr>
+          <a:xfrm>
+            <a:off x="7877176" y="5662610"/>
+            <a:ext cx="828673" cy="371470"/>
+          </a:xfrm>
+          <a:prstGeom prst="rect">
+            <a:avLst/>
+          </a:prstGeom>
+          <a:solidFill>
+            <a:schemeClr val="bg1"/>
+          </a:solidFill>
+          <a:ln>
+            <a:solidFill>
+              <a:schemeClr val="bg1"/>
+            </a:solidFill>
+          </a:ln>
+        </p:spPr>
+        <p:style>
+          <a:lnRef idx="2">
+            <a:schemeClr val="accent6"/>
+          </a:lnRef>
+          <a:fillRef idx="1">
+            <a:schemeClr val="lt1"/>
+          </a:fillRef>
+          <a:effectRef idx="0">
+            <a:schemeClr val="accent6"/>
+          </a:effectRef>
+          <a:fontRef idx="minor">
+            <a:schemeClr val="dk1"/>
+          </a:fontRef>
+        </p:style>
+        <p:txBody>
+          <a:bodyPr rtlCol="0" anchor="ctr"/>
+          <a:lstStyle/>
+          <a:p>
+            <a:pPr algn="ctr"/>
+            <a:endParaRPr lang="en-US"/>
+          </a:p>
+        </p:txBody>
+      </p:sp>
+    </p:spTree>
+    <p:extLst>
+      <p:ext uri="{BB962C8B-B14F-4D97-AF65-F5344CB8AC3E}">
+        <p14:creationId xmlns:p14="http://schemas.microsoft.com/office/powerpoint/2010/main" val="3317801591"/>
+      </p:ext>
+    </p:extLst>
+  </p:cSld>
+  <p:clrMapOvr>
+    <a:masterClrMapping/>
+  </p:clrMapOvr>
+</p:sld>
+</file>
+
 <file path=ppt/theme/theme1.xml><?xml version="1.0" encoding="utf-8"?>
 <a:theme xmlns:a="http://schemas.openxmlformats.org/drawingml/2006/main" name="Office Theme">
   <a:themeElements>

</xml_diff>